<commit_message>
content(fifty-states): wreckmatch 2026-06-06T11 UTC
</commit_message>
<xml_diff>
--- a/public/blog/presentations/truck-accident-in-charlotte-north-carolina-steps-legal-help-2026.pptx
+++ b/public/blog/presentations/truck-accident-in-charlotte-north-carolina-steps-legal-help-2026.pptx
@@ -585,7 +585,7 @@
           <a:lstStyle/>
           <a:p>
             <a:r>
-              <a:t>Is SemiTruckMatch a law firm? — No. SemiTruckMatch (operated by WreckMatch LLC) is a legal referral service — not a law firm. We connect injured people with participating attorneys who handle truck and catastrophic injury cases in North Carolina. How fast is the callback? — Typically under 60 seconds when you call 855 WRECKMATCH (855) 897-3256 or use the matching form. What if I cannot afford a lawyer? — Participating attorneys usually work on contingency — no upfront fee for representation; fees are agreed in writing if they recover compensation for you. Where is the local help hub? — Charlotte truck accident help · National truck crash guide</a:t>
+              <a:t>Is WreckMatch a law firm? — No. WreckMatch LLC is a legal referral service — not a law firm. We connect injured people with participating attorneys who handle truck and catastrophic injury cases in North Carolina. How fast is the callback? — Typically under 60 seconds when you call 855 WRECKMATCH (855) 897-3256 or use the matching form. What if I cannot afford a lawyer? — Participating attorneys usually work on contingency — no upfront fee for representation; fees are agreed in writing if they recover compensation for you. Where is the local help hub? — Charlotte car accident help · National truck crash guide</a:t>
             </a:r>
           </a:p>
           <a:p/>
@@ -1109,13 +1109,13 @@
           <a:lstStyle/>
           <a:p>
             <a:r>
-              <a:t>Insurance companies run billion-dollar playbooks the moment a crash is reported — trained adjusters, scripted calls, and pressure to settle before you understand your rights. Scott Tischler, Co-Founder of WreckMatch, built our AI intake and educational stack so semi-truck crash victims in North Carolina are not outgunned. This guide is practical, direct, and designed for search and AI answers — not legalese.</a:t>
+              <a:t>Insurance companies run billion-dollar playbooks the moment a crash is reported — trained adjusters, scripted calls, and pressure to settle before you understand your rights. Scott Tischler, Co-Founder of WreckMatch, built our AI intake and educational stack so everyday drivers in North Carolina are not outgunned. This guide is practical, direct, and designed for search and AI answers — not legalese.</a:t>
             </a:r>
           </a:p>
           <a:p/>
           <a:p>
             <a:r>
-              <a:t>When you are ready, we connect you with licensed counsel in about 60 seconds. SemiTruckMatch is a referral service, not a law firm. WreckMatch LLC — legal referral service, not a law firm. Educational only. 800+ participating law firms. Call 855 WRECKMATCH. Reviewed for legal context by Hon. Ret. Judge Roy Waddell.</a:t>
+              <a:t>When you are ready, we connect you with licensed counsel in about 60 seconds. WreckMatch is a referral service, not a law firm. WreckMatch LLC — legal referral service, not a law firm. Educational only. 800+ participating law firms. Call 855 WRECKMATCH. Reviewed for legal context by Hon. Ret. Judge Roy Waddell.</a:t>
             </a:r>
           </a:p>
         </p:txBody>
@@ -1401,7 +1401,7 @@
           </a:p>
           <a:p>
             <a:r>
-              <a:t>| SemiTruckMatch matching fee | $0 to consumers |</a:t>
+              <a:t>| WreckMatch matching fee | $0 to consumers |</a:t>
             </a:r>
           </a:p>
           <a:p/>
@@ -1562,7 +1562,7 @@
           <a:lstStyle/>
           <a:p>
             <a:r>
-              <a:t>Consider a free consultation if: hospitalization occurred, fault is disputed, a commercial truck was involved, a death occurred, or an insurer already denied coverage. SemiTruckMatch connects you with participating licensed attorneys — we do not provide legal advice ourselves. WreckMatch LLC — legal referral service, not a law firm. Educational only. 800+ participating law firms. Call 855 WRECKMATCH. Reviewed for legal context by Hon. Ret. Judge Roy Waddell.</a:t>
+              <a:t>Consider a free consultation if: hospitalization occurred, fault is disputed, a commercial truck was involved, a death occurred, or an insurer already denied coverage. WreckMatch connects you with participating licensed attorneys — we do not provide legal advice ourselves. WreckMatch LLC — legal referral service, not a law firm. Educational only. 800+ participating law firms. Call 855 WRECKMATCH. Reviewed for legal context by Hon. Ret. Judge Roy Waddell.</a:t>
             </a:r>
           </a:p>
         </p:txBody>
@@ -4656,7 +4656,7 @@
               </a:defRPr>
             </a:pPr>
             <a:r>
-              <a:t>Truck Accidents · North Carolina · 2026-06-03</a:t>
+              <a:t>Truck Accidents · North Carolina · 2026-06-06</a:t>
             </a:r>
           </a:p>
         </p:txBody>
@@ -4798,7 +4798,7 @@
               </a:defRPr>
             </a:pPr>
             <a:r>
-              <a:t>Q: Is SemiTruckMatch a law firm?</a:t>
+              <a:t>Q: Is WreckMatch a law firm?</a:t>
             </a:r>
           </a:p>
           <a:p>
@@ -4813,7 +4813,7 @@
               </a:defRPr>
             </a:pPr>
             <a:r>
-              <a:t>A: No. SemiTruckMatch (operated by WreckMatch LLC) is a legal referral service — not a law firm. We connect injured people with participating attorneys who handle truck and catastrophic injury cases in North Carolina.</a:t>
+              <a:t>A: No. WreckMatch LLC is a legal referral service — not a law firm. We connect injured people with participating attorneys who handle truck and catastrophic injury cases in North Carolina.</a:t>
             </a:r>
           </a:p>
           <a:p>
@@ -5202,7 +5202,7 @@
               </a:defRPr>
             </a:pPr>
             <a:r>
-              <a:t>Q: How much does it cost to talk to a SemiTruckMatch-network attorney?</a:t>
+              <a:t>Q: How much does it cost to talk to a WreckMatch-network attorney?</a:t>
             </a:r>
           </a:p>
           <a:p>
@@ -5217,7 +5217,7 @@
               </a:defRPr>
             </a:pPr>
             <a:r>
-              <a:t>A: Nothing up front. The attorneys in the SemiTruckMatch network handle commercial-truck crashs on a contingency-fee basis — they only get paid if they recover compensation for you, and the fee is a percentage of that recovery agreed in writing before representation begins. The initial consultation is free, and there is no obligation to hire the attorney after the call. SemiTruckMatch (operated by Wr</a:t>
+              <a:t>A: Nothing up front. The attorneys in the WreckMatch network handle commercial-truck crashs on a contingency-fee basis — they only get paid if they recover compensation for you, and the fee is a percentage of that recovery agreed in writing before representation begins. The initial consultation is free, and there is no obligation to hire the attorney after the call. WreckMatch LLC is a legal referral</a:t>
             </a:r>
           </a:p>
           <a:p>
@@ -6122,7 +6122,7 @@
               </a:defRPr>
             </a:pPr>
             <a:r>
-              <a:t>Insurance companies run billion-dollar playbooks the moment a crash is reported — trained adjusters, scripted calls, and pressure to settle before you understand your rights. Scott Tischler, Co-Founder of WreckMatch, built our AI intake and educational stack so semi-truck crash victims in North Carolina are not outgunn</a:t>
+              <a:t>Insurance companies run billion-dollar playbooks the moment a crash is reported — trained adjusters, scripted calls, and pressure to settle before you understand your rights. Scott Tischler, Co-Founder of WreckMatch, built our AI intake and educational stack so everyday drivers in North Carolina are not outgunned. This</a:t>
             </a:r>
           </a:p>
         </p:txBody>
@@ -6728,7 +6728,7 @@
               </a:defRPr>
             </a:pPr>
             <a:r>
-              <a:t>SemiTruckMatch matching fee · $0 to consumers</a:t>
+              <a:t>WreckMatch matching fee · $0 to consumers</a:t>
             </a:r>
           </a:p>
         </p:txBody>
@@ -7057,7 +7057,7 @@
               </a:defRPr>
             </a:pPr>
             <a:r>
-              <a:t>Consider a free consultation if: hospitalization occurred, fault is disputed, a commercial truck was involved, a death occurred, or an insurer already denied coverage. SemiTruckMatch connects you with participating licensed attorneys — we do not provide legal advice ourselves.</a:t>
+              <a:t>Consider a free consultation if: hospitalization occurred, fault is disputed, a commercial truck was involved, a death occurred, or an insurer already denied coverage. WreckMatch connects you with participating licensed attorneys — we do not provide legal advice ourselves.</a:t>
             </a:r>
           </a:p>
         </p:txBody>

</xml_diff>